<commit_message>
deck: latest data (Splunk/Oxford Economics May 2026, Uptime 2026, AWS us-east-1 Oct 2025) and US dollars throughout (Azure CostUSD)
Co-Authored-By: Claude Opus 5.5 <noreply@anthropic.com>
</commit_message>
<xml_diff>
--- a/docs/deck/DR-Agent-Azure-Day-2026.pptx
+++ b/docs/deck/DR-Agent-Azure-Day-2026.pptx
@@ -780,7 +780,7 @@
           <a:p>
             <a:r>
               <a:rPr lang="en-US" dirty="0"/>
-              <a:t>Cost is where this gets compelling. Every AI agent call we made across two days and nine drills cost ₹8.33 in total, from Azure Cost Management. The entire environment so far cost ₹234. At Azure list prices the DR set-up itself is $38.26 a month. Compare that with ITIC's floor of $300,000 an hour: a month of DR costs less than half a second of downtime.</a:t>
+              <a:t>Cost is where this gets compelling. Every AI agent call we made across two days and nine drills cost 9 cents in total, from Azure Cost Management. The entire environment so far cost $2.44. At Azure list prices the DR set-up itself is $38.26 a month. At the 2026 average of $15,000 a minute, a whole month of DR costs less than a fifth of a second of downtime.</a:t>
             </a:r>
             <a:endParaRPr lang="en-US" dirty="0"/>
           </a:p>
@@ -1132,7 +1132,7 @@
           <a:p>
             <a:r>
               <a:rPr lang="en-US" dirty="0"/>
-              <a:t>Start with money. ITIC's 2024 survey of over 1,000 firms: for more than 90% of mid-size and large enterprises one hour of downtime costs over $300,000, and 41% say $1M to over $5M, excluding fines and litigation. Splunk with Oxford Economics (June 2024, 2,000 executives): downtime costs each Global 2000 company about $200M a year, roughly 9% of profits, including $22M of regulatory fines. And in July 2024 one faulty update caused an estimated $5.4B of direct losses to the Fortune 500, $1.15B of it in banking. Simple arithmetic: $300K an hour is $5,000 a minute.</a:t>
+              <a:t>Start with money, using the latest research. Splunk with Oxford Economics, May 2026, 2,000 executives: downtime now costs Global 2000 companies $15,000 a minute on average, about $900,000 an hour and $600 billion a year, including $51 million a year in regulatory fines per company. Uptime Institute's 2026 analysis: 57% say their last major outage cost over $100,000, and one in five over $1 million. And in October 2025 a single AWS region outage cost US companies an estimated $500 to $650 million. Even hyperscalers fail; what matters is whether your recovery works.</a:t>
             </a:r>
             <a:endParaRPr lang="en-US" dirty="0"/>
           </a:p>
@@ -1220,7 +1220,7 @@
           <a:p>
             <a:r>
               <a:rPr lang="en-US" dirty="0"/>
-              <a:t>Closer to home, the penalty is a growth freeze. HDFC Bank: after repeated outages, the most recent a power failure at a primary data centre, the RBI stopped new digital launches and new credit cards in December 2020; cards resumed in August 2021, digital launches only in March 2022. NSE: a nearly four-hour trading halt in February 2021 ended in a ₹72.64 crore settlement with SEBI. Kotak Mahindra Bank: in April 2024 the RBI cited deficiencies including business continuity and disaster recovery, plus frequent outages, and stopped online onboarding and new cards for about ten months.</a:t>
+              <a:t>Closer to home, the penalty is a growth freeze. HDFC Bank: after repeated outages, the most recent a power failure at a primary data centre, the RBI stopped new digital launches and new credit cards in December 2020; cards resumed in August 2021, digital launches only in March 2022. NSE: a nearly four-hour trading halt in February 2021 ended in a settlement of about $8.8 million with SEBI. Kotak Mahindra Bank: in April 2024 the RBI cited deficiencies including business continuity and disaster recovery, plus frequent outages, and stopped online onboarding and new cards for about ten months.</a:t>
             </a:r>
             <a:endParaRPr lang="en-US" dirty="0"/>
           </a:p>
@@ -1396,7 +1396,7 @@
           <a:p>
             <a:r>
               <a:rPr lang="en-US" dirty="0"/>
-              <a:t>So why don't companies just test? Cockroach Labs surveyed 1,000 executives: fewer than one in three do regular failover testing, and only 20% feel fully prepared. Uptime Institute found 85% of major human-error outages come from procedures not followed or flawed procedures, which is exactly what a stale runbook is. The reasons are structural: tests are disruptive and manual, environments drift between tests, runbooks go stale, and RTO/RPO are signed off on paper instead of measured.</a:t>
+              <a:t>So why don't companies just test? Cockroach Labs surveyed 1,000 executives: fewer than one in three do regular failover testing, and only 20% feel fully prepared. Uptime Institute's 2026 analysis names failure to follow established procedures as the leading driver of human-error outages, which is exactly what a stale runbook causes. The reasons are structural: tests are disruptive and manual, environments drift between tests, runbooks go stale, and RTO/RPO are signed off on paper instead of measured.</a:t>
             </a:r>
             <a:endParaRPr lang="en-US" dirty="0"/>
           </a:p>
@@ -1484,7 +1484,7 @@
           <a:p>
             <a:r>
               <a:rPr lang="en-US" dirty="0"/>
-              <a:t>Put it together with transparent inputs. A tier-1 payments service with a 30-minute target that has never really been tested. On the day, recovery takes four hours, like the NSE halt. At ITIC's floor of $300,000 an hour, that is $1.2M of direct loss, $1.05M of it beyond the target, before any regulatory action: the NSE settlement was ₹72.64 crore, and the RBI froze HDFC's and Kotak's digital growth for 10 to 15 months. Our agent measured 34.35 seconds for the same kind of service, with zero payments lost, and it can prove it again every week.</a:t>
+              <a:t>Put it together with transparent inputs. A tier-1 payments service with a 30-minute target that has never really been tested. On the day, recovery takes four hours, like the NSE halt. At the 2026 average of $15,000 a minute, that is $3.6 million of direct loss, $3.15 million of it beyond the target, before any regulatory action: NSE paid about $8.8 million to settle, and the RBI froze HDFC's and Kotak's digital growth for 10 to 15 months. Our agent measured 34.35 seconds for the same kind of service, with zero payments lost, and it can prove it again on demand.</a:t>
             </a:r>
             <a:endParaRPr lang="en-US" dirty="0"/>
           </a:p>
@@ -5056,7 +5056,7 @@
                 <a:ea typeface="Calibri" pitchFamily="34" charset="-122"/>
                 <a:cs typeface="Calibri" pitchFamily="34" charset="-120"/>
               </a:rPr>
-              <a:t>₹8.33</a:t>
+              <a:t>$0.09</a:t>
             </a:r>
             <a:endParaRPr lang="en-US" sz="4000" dirty="0"/>
           </a:p>
@@ -5134,7 +5134,7 @@
                 <a:ea typeface="Calibri" pitchFamily="34" charset="-122"/>
                 <a:cs typeface="Calibri" pitchFamily="34" charset="-120"/>
               </a:rPr>
-              <a:t>every Foundry agent run across 2 days of building and 9 drills (Azure Cost Management) [13]</a:t>
+              <a:t>every Foundry agent run across 2 days of building and 9 drills: $0.087 (Azure Cost Management) [12]</a:t>
             </a:r>
             <a:endParaRPr lang="en-US" sz="1150" dirty="0"/>
           </a:p>
@@ -5207,7 +5207,7 @@
                 <a:ea typeface="Calibri" pitchFamily="34" charset="-122"/>
                 <a:cs typeface="Calibri" pitchFamily="34" charset="-120"/>
               </a:rPr>
-              <a:t>₹234</a:t>
+              <a:t>$2.44</a:t>
             </a:r>
             <a:endParaRPr lang="en-US" sz="4000" dirty="0"/>
           </a:p>
@@ -5285,7 +5285,7 @@
                 <a:ea typeface="Calibri" pitchFamily="34" charset="-122"/>
                 <a:cs typeface="Calibri" pitchFamily="34" charset="-120"/>
               </a:rPr>
-              <a:t>two regions, database, VM, console, monitoring: everything, 17–18 Oct 2026 [13]</a:t>
+              <a:t>two regions, database, VM, console, monitoring: everything, 17–18 Oct 2026 (Azure Cost Management) [12]</a:t>
             </a:r>
             <a:endParaRPr lang="en-US" sz="1150" dirty="0"/>
           </a:p>
@@ -5436,7 +5436,7 @@
                 <a:ea typeface="Calibri" pitchFamily="34" charset="-122"/>
                 <a:cs typeface="Calibri" pitchFamily="34" charset="-120"/>
               </a:rPr>
-              <a:t>both regions + Traffic Manager at Azure list prices (Retail Prices API) [14]</a:t>
+              <a:t>both regions + Traffic Manager at Azure list prices (Retail Prices API) [13]</a:t>
             </a:r>
             <a:endParaRPr lang="en-US" sz="1150" dirty="0"/>
           </a:p>
@@ -5502,7 +5502,7 @@
                 <a:ea typeface="Calibri" pitchFamily="34" charset="-122"/>
                 <a:cs typeface="Calibri" pitchFamily="34" charset="-120"/>
               </a:rPr>
-              <a:t>A month of this DR set-up costs less than half a second of downtime </a:t>
+              <a:t>A month of this DR set-up costs less than a fifth of a second of downtime </a:t>
             </a:r>
             <a:pPr indent="0" marL="0">
               <a:buNone/>
@@ -5516,7 +5516,7 @@
                 <a:ea typeface="Calibri" pitchFamily="34" charset="-122"/>
                 <a:cs typeface="Calibri" pitchFamily="34" charset="-120"/>
               </a:rPr>
-              <a:t>at the ITIC floor of $300,000 an hour ($38.26 ÷ $83.33 per second = 0.46 s). [1][14]</a:t>
+              <a:t>at the 2026 average of $15,000 a minute ($38.26 ÷ $250 per second = 0.15 s). [1][13]</a:t>
             </a:r>
             <a:endParaRPr lang="en-US" sz="1600" dirty="0"/>
           </a:p>
@@ -6919,7 +6919,7 @@
                 <a:ea typeface="Calibri" pitchFamily="34" charset="-122"/>
                 <a:cs typeface="Calibri" pitchFamily="34" charset="-120"/>
               </a:rPr>
-              <a:t>[1] ITIC, 2024 Hourly Cost of Downtime Survey, Part 2 (L. DiDio), 1,000+ firms, Nov 2023–Mar 2024. calyptix.com/wp-content/uploads/ITIC-2024-Hourly-Cost-of-Downtime-Survey-Results-Part-2.pdf</a:t>
+              <a:t>[1] Splunk with Oxford Economics, The Hidden Costs of Downtime 2026, 19 May 2026 (2,000 Global 2000 executives). newsroom.cisco.com (The $600 Billion Wake-up Call)</a:t>
             </a:r>
             <a:endParaRPr lang="en-US" sz="1050" dirty="0"/>
           </a:p>
@@ -6939,7 +6939,7 @@
                 <a:ea typeface="Calibri" pitchFamily="34" charset="-122"/>
                 <a:cs typeface="Calibri" pitchFamily="34" charset="-120"/>
               </a:rPr>
-              <a:t>[2] Splunk with Oxford Economics, The Hidden Costs of Downtime, 12 Jun 2024. splunk.com/en_us/blog/cio-office/uncovering-downtime.html</a:t>
+              <a:t>[2] Uptime Institute, Annual Outage Analysis 2026, press release 13 May 2026. uptimeinstitute.com</a:t>
             </a:r>
             <a:endParaRPr lang="en-US" sz="1050" dirty="0"/>
           </a:p>
@@ -6959,7 +6959,7 @@
                 <a:ea typeface="Calibri" pitchFamily="34" charset="-122"/>
                 <a:cs typeface="Calibri" pitchFamily="34" charset="-120"/>
               </a:rPr>
-              <a:t>[3] Parametrix estimate of CrowdStrike outage losses (19 Jul 2024), reported by Dark Reading and Cybersecurity Dive, Jul 2024. darkreading.com/cybersecurity-operations/crowdstrike-outage-losses-estimated-staggering-54b</a:t>
+              <a:t>[3] Parametrix estimate of losses from the AWS us-east-1 outage of 20 Oct 2025 (Insurance Edge, 30 Oct 2025).</a:t>
             </a:r>
             <a:endParaRPr lang="en-US" sz="1050" dirty="0"/>
           </a:p>
@@ -6999,7 +6999,7 @@
                 <a:ea typeface="Calibri" pitchFamily="34" charset="-122"/>
                 <a:cs typeface="Calibri" pitchFamily="34" charset="-120"/>
               </a:rPr>
-              <a:t>[5] NSE and NSE Clearing settle the 24 Feb 2021 trading-halt case with SEBI for ₹72.64 crore (Moneylife; Business Standard, Jun 2023).</a:t>
+              <a:t>[5] NSE and NSE Clearing settle the 24 Feb 2021 trading-halt case with SEBI for ₹72.64 crore (Moneylife; Business Standard, Jun 2023); ≈ $8.8M at June 2023 rates of ₹82–83 per US$.</a:t>
             </a:r>
             <a:endParaRPr lang="en-US" sz="1050" dirty="0"/>
           </a:p>
@@ -7139,7 +7139,7 @@
                 <a:ea typeface="Calibri" pitchFamily="34" charset="-122"/>
                 <a:cs typeface="Calibri" pitchFamily="34" charset="-120"/>
               </a:rPr>
-              <a:t>[12] Uptime Institute, Annual Outage Analysis 2025, press release 6 May 2025. uptimeinstitute.com</a:t>
+              <a:t>[12] Azure Cost Management, actual cost by service in US$ (CostUSD), month to date, queried 18 Oct 2026 (our environment).</a:t>
             </a:r>
             <a:endParaRPr lang="en-US" sz="1050" dirty="0"/>
           </a:p>
@@ -7159,27 +7159,7 @@
                 <a:ea typeface="Calibri" pitchFamily="34" charset="-122"/>
                 <a:cs typeface="Calibri" pitchFamily="34" charset="-120"/>
               </a:rPr>
-              <a:t>[13] Azure Cost Management, subscription actual cost by service, month to date, queried 18 Oct 2026 (our environment).</a:t>
-            </a:r>
-            <a:endParaRPr lang="en-US" sz="1050" dirty="0"/>
-          </a:p>
-          <a:p>
-            <a:pPr indent="0" marL="0">
-              <a:spcAft>
-                <a:spcPts val="500"/>
-              </a:spcAft>
-              <a:buNone/>
-            </a:pPr>
-            <a:r>
-              <a:rPr lang="en-US" sz="1050" dirty="0">
-                <a:solidFill>
-                  <a:srgbClr val="1B2635"/>
-                </a:solidFill>
-                <a:latin typeface="Calibri" pitchFamily="34" charset="0"/>
-                <a:ea typeface="Calibri" pitchFamily="34" charset="-122"/>
-                <a:cs typeface="Calibri" pitchFamily="34" charset="-120"/>
-              </a:rPr>
-              <a:t>[14] Azure Retail Prices API (prices.azure.com), East Asia / Southeast Asia list prices for App Service B1 Linux, SQL Database Basic, Traffic Manager, 18 Oct 2026.</a:t>
+              <a:t>[13] Azure Retail Prices API (prices.azure.com), East Asia / Southeast Asia list prices for App Service B1 Linux, SQL Database Basic, Traffic Manager, 18 Oct 2026.</a:t>
             </a:r>
             <a:endParaRPr lang="en-US" sz="1050" dirty="0"/>
           </a:p>
@@ -7675,7 +7655,7 @@
                 <a:ea typeface="Calibri" pitchFamily="34" charset="-122"/>
                 <a:cs typeface="Calibri" pitchFamily="34" charset="-120"/>
               </a:rPr>
-              <a:t>One hour of downtime now costs more than most DR budgets</a:t>
+              <a:t>Downtime now costs about $900,000 an hour</a:t>
             </a:r>
             <a:endParaRPr lang="en-US" sz="3200" dirty="0"/>
           </a:p>
@@ -7714,7 +7694,7 @@
                 <a:ea typeface="Calibri" pitchFamily="34" charset="-122"/>
                 <a:cs typeface="Calibri" pitchFamily="34" charset="-120"/>
               </a:rPr>
-              <a:t>Independent surveys and real incidents, 2024: the cost of not recovering on time.</a:t>
+              <a:t>The latest independent research (2026) and a 2025 cloud outage: the cost of not recovering on time.</a:t>
             </a:r>
             <a:endParaRPr lang="en-US" sz="1500" dirty="0"/>
           </a:p>
@@ -7779,7 +7759,7 @@
               <a:buNone/>
             </a:pPr>
             <a:r>
-              <a:rPr lang="en-US" sz="4800" b="1" dirty="0">
+              <a:rPr lang="en-US" sz="4200" b="1" dirty="0">
                 <a:solidFill>
                   <a:srgbClr val="5E2CFE"/>
                 </a:solidFill>
@@ -7787,9 +7767,9 @@
                 <a:ea typeface="Calibri" pitchFamily="34" charset="-122"/>
                 <a:cs typeface="Calibri" pitchFamily="34" charset="-120"/>
               </a:rPr>
-              <a:t>$300K+</a:t>
-            </a:r>
-            <a:endParaRPr lang="en-US" sz="4800" dirty="0"/>
+              <a:t>$15,000</a:t>
+            </a:r>
+            <a:endParaRPr lang="en-US" sz="4200" dirty="0"/>
           </a:p>
         </p:txBody>
       </p:sp>
@@ -7826,7 +7806,7 @@
                 <a:ea typeface="Calibri" pitchFamily="34" charset="-122"/>
                 <a:cs typeface="Calibri" pitchFamily="34" charset="-120"/>
               </a:rPr>
-              <a:t>per hour of downtime</a:t>
+              <a:t>per minute of downtime</a:t>
             </a:r>
             <a:endParaRPr lang="en-US" sz="1600" dirty="0"/>
           </a:p>
@@ -7865,7 +7845,7 @@
                 <a:ea typeface="Calibri" pitchFamily="34" charset="-122"/>
                 <a:cs typeface="Calibri" pitchFamily="34" charset="-120"/>
               </a:rPr>
-              <a:t>for over 90% of mid-size and large enterprises. 41% put it at $1M to over $5M per hour, before fines and litigation.</a:t>
+              <a:t>is the average for Global 2000 companies: about $900,000 an hour and $600B a year in total. Regulatory fines alone average $51M per company a year.</a:t>
             </a:r>
             <a:endParaRPr lang="en-US" sz="1300" dirty="0"/>
           </a:p>
@@ -7904,7 +7884,7 @@
                 <a:ea typeface="Calibri" pitchFamily="34" charset="-122"/>
                 <a:cs typeface="Calibri" pitchFamily="34" charset="-120"/>
               </a:rPr>
-              <a:t>ITIC 2024 Hourly Cost of Downtime Survey (1,000+ firms) [1]</a:t>
+              <a:t>Splunk &amp; Oxford Economics, The Hidden Costs of Downtime, May 2026 (2,000 executives) [1]</a:t>
             </a:r>
             <a:endParaRPr lang="en-US" sz="950" dirty="0"/>
           </a:p>
@@ -7969,7 +7949,7 @@
               <a:buNone/>
             </a:pPr>
             <a:r>
-              <a:rPr lang="en-US" sz="4800" b="1" dirty="0">
+              <a:rPr lang="en-US" sz="4200" b="1" dirty="0">
                 <a:solidFill>
                   <a:srgbClr val="5E2CFE"/>
                 </a:solidFill>
@@ -7977,9 +7957,9 @@
                 <a:ea typeface="Calibri" pitchFamily="34" charset="-122"/>
                 <a:cs typeface="Calibri" pitchFamily="34" charset="-120"/>
               </a:rPr>
-              <a:t>$200M</a:t>
-            </a:r>
-            <a:endParaRPr lang="en-US" sz="4800" dirty="0"/>
+              <a:t>57%</a:t>
+            </a:r>
+            <a:endParaRPr lang="en-US" sz="4200" dirty="0"/>
           </a:p>
         </p:txBody>
       </p:sp>
@@ -8016,7 +7996,7 @@
                 <a:ea typeface="Calibri" pitchFamily="34" charset="-122"/>
                 <a:cs typeface="Calibri" pitchFamily="34" charset="-120"/>
               </a:rPr>
-              <a:t>per company, every year</a:t>
+              <a:t>had a last major outage over $100K</a:t>
             </a:r>
             <a:endParaRPr lang="en-US" sz="1600" dirty="0"/>
           </a:p>
@@ -8055,7 +8035,7 @@
                 <a:ea typeface="Calibri" pitchFamily="34" charset="-122"/>
                 <a:cs typeface="Calibri" pitchFamily="34" charset="-120"/>
               </a:rPr>
-              <a:t>lost to downtime by each Global 2000 company: about 9% of profits. Includes $49M lost revenue and $22M in regulatory fines.</a:t>
+              <a:t>and 1 in 5 operators said their last major outage cost more than $1 million, for the second year running.</a:t>
             </a:r>
             <a:endParaRPr lang="en-US" sz="1300" dirty="0"/>
           </a:p>
@@ -8094,7 +8074,7 @@
                 <a:ea typeface="Calibri" pitchFamily="34" charset="-122"/>
                 <a:cs typeface="Calibri" pitchFamily="34" charset="-120"/>
               </a:rPr>
-              <a:t>Splunk &amp; Oxford Economics, The Hidden Costs of Downtime, Jun 2024 (2,000 executives) [2]</a:t>
+              <a:t>Uptime Institute, Annual Outage Analysis 2026 [2]</a:t>
             </a:r>
             <a:endParaRPr lang="en-US" sz="950" dirty="0"/>
           </a:p>
@@ -8159,7 +8139,7 @@
               <a:buNone/>
             </a:pPr>
             <a:r>
-              <a:rPr lang="en-US" sz="4800" b="1" dirty="0">
+              <a:rPr lang="en-US" sz="4200" b="1" dirty="0">
                 <a:solidFill>
                   <a:srgbClr val="5E2CFE"/>
                 </a:solidFill>
@@ -8167,9 +8147,9 @@
                 <a:ea typeface="Calibri" pitchFamily="34" charset="-122"/>
                 <a:cs typeface="Calibri" pitchFamily="34" charset="-120"/>
               </a:rPr>
-              <a:t>$5.4B</a:t>
-            </a:r>
-            <a:endParaRPr lang="en-US" sz="4800" dirty="0"/>
+              <a:t>$500–650M</a:t>
+            </a:r>
+            <a:endParaRPr lang="en-US" sz="4200" dirty="0"/>
           </a:p>
         </p:txBody>
       </p:sp>
@@ -8206,7 +8186,7 @@
                 <a:ea typeface="Calibri" pitchFamily="34" charset="-122"/>
                 <a:cs typeface="Calibri" pitchFamily="34" charset="-120"/>
               </a:rPr>
-              <a:t>from one IT outage</a:t>
+              <a:t>from one cloud-region outage</a:t>
             </a:r>
             <a:endParaRPr lang="en-US" sz="1600" dirty="0"/>
           </a:p>
@@ -8245,7 +8225,7 @@
                 <a:ea typeface="Calibri" pitchFamily="34" charset="-122"/>
                 <a:cs typeface="Calibri" pitchFamily="34" charset="-120"/>
               </a:rPr>
-              <a:t>in direct losses to Fortune 500 companies from the 19 July 2024 CrowdStrike incident; banking alone about $1.15B. Insurance covers only 10–20%.</a:t>
+              <a:t>lost by US companies when AWS us-east-1 failed on 20 October 2025. Even hyperscalers fail; what matters is whether your recovery works.</a:t>
             </a:r>
             <a:endParaRPr lang="en-US" sz="1300" dirty="0"/>
           </a:p>
@@ -8284,7 +8264,7 @@
                 <a:ea typeface="Calibri" pitchFamily="34" charset="-122"/>
                 <a:cs typeface="Calibri" pitchFamily="34" charset="-120"/>
               </a:rPr>
-              <a:t>Parametrix estimate, Jul 2024 [3]</a:t>
+              <a:t>Parametrix estimate, Oct 2025 [3]</a:t>
             </a:r>
             <a:endParaRPr lang="en-US" sz="950" dirty="0"/>
           </a:p>
@@ -8350,7 +8330,7 @@
                 <a:ea typeface="Calibri" pitchFamily="34" charset="-122"/>
                 <a:cs typeface="Calibri" pitchFamily="34" charset="-120"/>
               </a:rPr>
-              <a:t>At $300K per hour, every minute of downtime costs about $5,000.</a:t>
+              <a:t>At $15,000 a minute, one hour of downtime costs about $900,000.</a:t>
             </a:r>
             <a:pPr indent="0" marL="0">
               <a:buNone/>
@@ -9017,7 +8997,7 @@
                 <a:ea typeface="Calibri" pitchFamily="34" charset="-122"/>
                 <a:cs typeface="Calibri" pitchFamily="34" charset="-120"/>
               </a:rPr>
-              <a:t>₹72.64 crore</a:t>
+              <a:t>≈ $8.8M</a:t>
             </a:r>
             <a:endParaRPr lang="en-US" sz="3400" dirty="0"/>
           </a:p>
@@ -9056,7 +9036,7 @@
                 <a:ea typeface="Calibri" pitchFamily="34" charset="-122"/>
                 <a:cs typeface="Calibri" pitchFamily="34" charset="-120"/>
               </a:rPr>
-              <a:t>paid by NSE and NSE Clearing to settle (2023)</a:t>
+              <a:t>paid by NSE and NSE Clearing to settle with SEBI (2023)</a:t>
             </a:r>
             <a:endParaRPr lang="en-US" sz="1200" dirty="0"/>
           </a:p>
@@ -10200,7 +10180,7 @@
                           <a:ea typeface="Calibri" pitchFamily="34" charset="-122"/>
                           <a:cs typeface="Calibri" pitchFamily="34" charset="-120"/>
                         </a:rPr>
-                        <a:t>Enforcement and settlements, as with NSE: ₹72.64 crore. [5]</a:t>
+                        <a:t>Enforcement and settlements, as with NSE: about $8.8M. [5]</a:t>
                       </a:r>
                       <a:endParaRPr lang="en-US" sz="1200" dirty="0">
                         <a:latin typeface="Calibri" charset="0"/>
@@ -11069,7 +11049,7 @@
                 <a:ea typeface="Calibri" pitchFamily="34" charset="-122"/>
                 <a:cs typeface="Calibri" pitchFamily="34" charset="-120"/>
               </a:rPr>
-              <a:t>85%</a:t>
+              <a:t>#1</a:t>
             </a:r>
             <a:endParaRPr lang="en-US" sz="3800" dirty="0"/>
           </a:p>
@@ -11108,7 +11088,7 @@
                 <a:ea typeface="Calibri" pitchFamily="34" charset="-122"/>
                 <a:cs typeface="Calibri" pitchFamily="34" charset="-120"/>
               </a:rPr>
-              <a:t>of major human-error outages come from staff not following procedures, or from flawed procedures</a:t>
+              <a:t>cause of human-error outages: staff not following established procedures</a:t>
             </a:r>
             <a:endParaRPr lang="en-US" sz="1350" dirty="0"/>
           </a:p>
@@ -11147,7 +11127,7 @@
                 <a:ea typeface="Calibri" pitchFamily="34" charset="-122"/>
                 <a:cs typeface="Calibri" pitchFamily="34" charset="-120"/>
               </a:rPr>
-              <a:t>Uptime Institute, Annual Outage Analysis 2025 [12]</a:t>
+              <a:t>Uptime Institute, Annual Outage Analysis 2026 [2]</a:t>
             </a:r>
             <a:endParaRPr lang="en-US" sz="950" dirty="0"/>
           </a:p>
@@ -12236,7 +12216,7 @@
                 <a:ea typeface="Calibri" pitchFamily="34" charset="-122"/>
                 <a:cs typeface="Calibri" pitchFamily="34" charset="-120"/>
               </a:rPr>
-              <a:t>$300,000</a:t>
+              <a:t>$900,000</a:t>
             </a:r>
             <a:endParaRPr lang="en-US" sz="2200" dirty="0"/>
           </a:p>
@@ -12275,7 +12255,7 @@
                 <a:ea typeface="Calibri" pitchFamily="34" charset="-122"/>
                 <a:cs typeface="Calibri" pitchFamily="34" charset="-120"/>
               </a:rPr>
-              <a:t>ITIC 2024 floor for 90%+ of mid-size and large firms [1]</a:t>
+              <a:t>$15,000 a minute, the Global 2000 average (Splunk &amp; Oxford Economics, 2026) [1]</a:t>
             </a:r>
             <a:endParaRPr lang="en-US" sz="1200" dirty="0"/>
           </a:p>
@@ -12380,7 +12360,7 @@
                 <a:ea typeface="Calibri" pitchFamily="34" charset="-122"/>
                 <a:cs typeface="Calibri" pitchFamily="34" charset="-120"/>
               </a:rPr>
-              <a:t>$1.2M</a:t>
+              <a:t>$3.6M</a:t>
             </a:r>
             <a:endParaRPr lang="en-US" sz="2200" dirty="0"/>
           </a:p>
@@ -12419,7 +12399,7 @@
                 <a:ea typeface="Calibri" pitchFamily="34" charset="-122"/>
                 <a:cs typeface="Calibri" pitchFamily="34" charset="-120"/>
               </a:rPr>
-              <a:t>4 h × $300K; $1.05M of it beyond the 30-minute target</a:t>
+              <a:t>4 h × $900K; $3.15M of it beyond the 30-minute target</a:t>
             </a:r>
             <a:endParaRPr lang="en-US" sz="1200" dirty="0"/>
           </a:p>
@@ -12524,7 +12504,7 @@
                 <a:ea typeface="Calibri" pitchFamily="34" charset="-122"/>
                 <a:cs typeface="Calibri" pitchFamily="34" charset="-120"/>
               </a:rPr>
-              <a:t>₹72.64 crore</a:t>
+              <a:t>≈ $8.8M</a:t>
             </a:r>
             <a:endParaRPr lang="en-US" sz="2200" dirty="0"/>
           </a:p>

</xml_diff>

<commit_message>
honest RPO: first write-by-write drill lost 2 of 45 acknowledged writes in the forced failover (2.8 s); real ASR time 3 min 08 s
- phone says payments in the last N s may need retrying when RPO > 0 (was 'your payments are safe')
- RPO evidence lists the lost writes for auditors
- deck: latest drill 29.04 s RTO, RPO 2.8 s, ASR job 3 min 08 s (verified inside VM at 3 min 55 s), 10 drills; tech-decisions corrected

Co-Authored-By: Claude Opus 5.5 <noreply@anthropic.com>
</commit_message>
<xml_diff>
--- a/docs/deck/DR-Agent-Azure-Day-2026.pptx
+++ b/docs/deck/DR-Agent-Azure-Day-2026.pptx
@@ -692,7 +692,7 @@
           <a:p>
             <a:r>
               <a:rPr lang="en-US" dirty="0"/>
-              <a:t>These are measured, not estimated. Eight drills without chaos: RTO between 29.6 and 40.4 seconds, median 33.5, against a 30-minute target; RPO zero every time. Failback about three minutes with no data loss. The reports VM was recovered by Site Recovery in under six minutes and proven by running a command inside it. And every second of RTO is accounted for: the latest 34.35 seconds split into 15.4 s SQL failover, 5.9 s Traffic Manager, 11.6 s DNS and health checks, and under a second each for the injection and our own bookkeeping.</a:t>
+              <a:t>These are measured, not estimated. Nine drills without chaos: RTO between 29.0 and 40.4 seconds, median 32.7, against a 30-minute target. RPO is proven write by write: in the latest drill the old primary acknowledged 6 writes while the forced failover was running, and 2 of them never reached the new primary, so 2.8 seconds of writes were lost, against a 15-minute target. That is exactly what a forced failover with asynchronous replication means, and our own audit found that our first, narrower measurement had missed it. Failback is planned and loses nothing. Site Recovery brought the reports VM up in Southeast Asia in 3 minutes 8 seconds, and we proved the service inside it at 3 minutes 55. Every second of the latest 29.04 s RTO is accounted for: 14.3 s SQL failover, 3.8 s Traffic Manager, 9.5 s DNS and health checks, and under a second each for the injection and our own bookkeeping.</a:t>
             </a:r>
             <a:endParaRPr lang="en-US" dirty="0"/>
           </a:p>
@@ -1484,7 +1484,7 @@
           <a:p>
             <a:r>
               <a:rPr lang="en-US" dirty="0"/>
-              <a:t>Put it together with transparent inputs. A tier-1 payments service with a 30-minute target that has never really been tested. On the day, recovery takes four hours, like the NSE halt. At the 2026 average of $15,000 a minute, that is $3.6 million of direct loss, $3.15 million of it beyond the target, before any regulatory action: NSE paid about $8.8 million to settle, and the RBI froze HDFC's and Kotak's digital growth for 10 to 15 months. Our agent measured 34.35 seconds for the same kind of service, with zero payments lost, and it can prove it again on demand.</a:t>
+              <a:t>Put it together with transparent inputs. A tier-1 payments service with a 30-minute target that has never really been tested. On the day, recovery takes four hours, like the NSE halt. At the 2026 average of $15,000 a minute, that is $3.6 million of direct loss, $3.15 million of it beyond the target, before any regulatory action: NSE paid about $8.8 million to settle, and the RBI froze HDFC's and Kotak's digital growth for 10 to 15 months. Our agent measured 29.04 seconds for the same kind of service, and proved the data loss write by write: 2.8 seconds of writes, against a 15-minute target. It can prove it again on demand.</a:t>
             </a:r>
             <a:endParaRPr lang="en-US" dirty="0"/>
           </a:p>
@@ -2821,7 +2821,7 @@
                 <a:ea typeface="Calibri" pitchFamily="34" charset="-122"/>
                 <a:cs typeface="Calibri" pitchFamily="34" charset="-120"/>
               </a:rPr>
-              <a:t>East Asia (primary) and Southeast Asia (DR). The control plane runs outside both, in South India, so it survives the disaster it manages.</a:t>
+              <a:t>East Asia (primary) and Southeast Asia (DR). The control plane runs outside both: console in South India, its state and secrets in Central India, agents in East US 2.</a:t>
             </a:r>
             <a:endParaRPr lang="en-US" sz="1500" dirty="0"/>
           </a:p>
@@ -3549,7 +3549,7 @@
                 <a:ea typeface="Calibri" pitchFamily="34" charset="-122"/>
                 <a:cs typeface="Calibri" pitchFamily="34" charset="-120"/>
               </a:rPr>
-              <a:t>Real failovers of the payments service, East Asia → Southeast Asia, 17–18 Oct 2026. Target: RTO 30 min, RPO 15 min.</a:t>
+              <a:t>Real failovers of the payments service, East Asia → Southeast Asia, 17–19 Oct 2026. Target: RTO 30 min, RPO 15 min.</a:t>
             </a:r>
             <a:endParaRPr lang="en-US" sz="1500" dirty="0"/>
           </a:p>
@@ -3622,7 +3622,7 @@
                 <a:ea typeface="Calibri" pitchFamily="34" charset="-122"/>
                 <a:cs typeface="Calibri" pitchFamily="34" charset="-120"/>
               </a:rPr>
-              <a:t>34.35 s</a:t>
+              <a:t>29.04 s</a:t>
             </a:r>
             <a:endParaRPr lang="en-US" sz="3000" dirty="0"/>
           </a:p>
@@ -3700,7 +3700,7 @@
                 <a:ea typeface="Calibri" pitchFamily="34" charset="-122"/>
                 <a:cs typeface="Calibri" pitchFamily="34" charset="-120"/>
               </a:rPr>
-              <a:t>29.6–40.4 s across 8 drills (median 33.5 s)</a:t>
+              <a:t>29.0–40.4 s across 9 drills (median 32.7 s)</a:t>
             </a:r>
             <a:endParaRPr lang="en-US" sz="1100" dirty="0"/>
           </a:p>
@@ -3773,7 +3773,7 @@
                 <a:ea typeface="Calibri" pitchFamily="34" charset="-122"/>
                 <a:cs typeface="Calibri" pitchFamily="34" charset="-120"/>
               </a:rPr>
-              <a:t>0 s</a:t>
+              <a:t>2.8 s</a:t>
             </a:r>
             <a:endParaRPr lang="en-US" sz="3000" dirty="0"/>
           </a:p>
@@ -3812,7 +3812,7 @@
                 <a:ea typeface="Calibri" pitchFamily="34" charset="-122"/>
                 <a:cs typeface="Calibri" pitchFamily="34" charset="-120"/>
               </a:rPr>
-              <a:t>RPO, every drill</a:t>
+              <a:t>RPO, proven write by write</a:t>
             </a:r>
             <a:endParaRPr lang="en-US" sz="1300" dirty="0"/>
           </a:p>
@@ -3851,7 +3851,7 @@
                 <a:ea typeface="Calibri" pitchFamily="34" charset="-122"/>
                 <a:cs typeface="Calibri" pitchFamily="34" charset="-120"/>
               </a:rPr>
-              <a:t>no confirmed payment lost (1 s heartbeat proof)</a:t>
+              <a:t>2 of 45 acknowledged writes lost in the forced failover</a:t>
             </a:r>
             <a:endParaRPr lang="en-US" sz="1100" dirty="0"/>
           </a:p>
@@ -3924,7 +3924,7 @@
                 <a:ea typeface="Calibri" pitchFamily="34" charset="-122"/>
                 <a:cs typeface="Calibri" pitchFamily="34" charset="-120"/>
               </a:rPr>
-              <a:t>3 min 14 s</a:t>
+              <a:t>3 min 44 s</a:t>
             </a:r>
             <a:endParaRPr lang="en-US" sz="3000" dirty="0"/>
           </a:p>
@@ -4075,7 +4075,7 @@
                 <a:ea typeface="Calibri" pitchFamily="34" charset="-122"/>
                 <a:cs typeface="Calibri" pitchFamily="34" charset="-120"/>
               </a:rPr>
-              <a:t>5 min 45 s</a:t>
+              <a:t>3 min 08 s</a:t>
             </a:r>
             <a:endParaRPr lang="en-US" sz="3000" dirty="0"/>
           </a:p>
@@ -4153,7 +4153,7 @@
                 <a:ea typeface="Calibri" pitchFamily="34" charset="-122"/>
                 <a:cs typeface="Calibri" pitchFamily="34" charset="-120"/>
               </a:rPr>
-              <a:t>proven by a command inside the VM</a:t>
+              <a:t>test-failover job; service verified inside the VM at 3 min 55 s</a:t>
             </a:r>
             <a:endParaRPr lang="en-US" sz="1100" dirty="0"/>
           </a:p>
@@ -4192,7 +4192,7 @@
                 <a:ea typeface="Calibri" pitchFamily="34" charset="-122"/>
                 <a:cs typeface="Calibri" pitchFamily="34" charset="-120"/>
               </a:rPr>
-              <a:t>Where the 34.35 s went (latest drill, one clock, segments add up exactly)</a:t>
+              <a:t>Where the 29.04 s went (latest drill, one clock, segments add up exactly)</a:t>
             </a:r>
             <a:endParaRPr lang="en-US" sz="1400" dirty="0"/>
           </a:p>
@@ -4207,7 +4207,7 @@
         <p:spPr>
           <a:xfrm>
             <a:off x="548640" y="3977640"/>
-            <a:ext cx="167157" cy="457200"/>
+            <a:ext cx="272034" cy="457200"/>
           </a:xfrm>
           <a:prstGeom prst="rect">
             <a:avLst/>
@@ -4231,8 +4231,8 @@
         </p:nvSpPr>
         <p:spPr>
           <a:xfrm>
-            <a:off x="715797" y="3977640"/>
-            <a:ext cx="4945461" cy="457200"/>
+            <a:off x="820674" y="3977640"/>
+            <a:ext cx="5456301" cy="457200"/>
           </a:xfrm>
           <a:prstGeom prst="rect">
             <a:avLst/>
@@ -4256,8 +4256,8 @@
         </p:nvSpPr>
         <p:spPr>
           <a:xfrm>
-            <a:off x="715797" y="3977640"/>
-            <a:ext cx="4945461" cy="457200"/>
+            <a:off x="820674" y="3977640"/>
+            <a:ext cx="5456301" cy="457200"/>
           </a:xfrm>
           <a:prstGeom prst="rect">
             <a:avLst/>
@@ -4281,7 +4281,7 @@
                 <a:ea typeface="Calibri" pitchFamily="34" charset="-122"/>
                 <a:cs typeface="Calibri" pitchFamily="34" charset="-120"/>
               </a:rPr>
-              <a:t>15.355 s</a:t>
+              <a:t>14.321 s</a:t>
             </a:r>
             <a:endParaRPr lang="en-US" sz="1200" dirty="0"/>
           </a:p>
@@ -4295,8 +4295,8 @@
         </p:nvSpPr>
         <p:spPr>
           <a:xfrm>
-            <a:off x="5661257" y="3977640"/>
-            <a:ext cx="1905395" cy="457200"/>
+            <a:off x="6276975" y="3977640"/>
+            <a:ext cx="1440942" cy="457200"/>
           </a:xfrm>
           <a:prstGeom prst="rect">
             <a:avLst/>
@@ -4320,8 +4320,8 @@
         </p:nvSpPr>
         <p:spPr>
           <a:xfrm>
-            <a:off x="5661257" y="3977640"/>
-            <a:ext cx="1905395" cy="457200"/>
+            <a:off x="6276975" y="3977640"/>
+            <a:ext cx="1440942" cy="457200"/>
           </a:xfrm>
           <a:prstGeom prst="rect">
             <a:avLst/>
@@ -4345,7 +4345,7 @@
                 <a:ea typeface="Calibri" pitchFamily="34" charset="-122"/>
                 <a:cs typeface="Calibri" pitchFamily="34" charset="-120"/>
               </a:rPr>
-              <a:t>5.916 s</a:t>
+              <a:t>3.782 s</a:t>
             </a:r>
             <a:endParaRPr lang="en-US" sz="1200" dirty="0"/>
           </a:p>
@@ -4359,8 +4359,8 @@
         </p:nvSpPr>
         <p:spPr>
           <a:xfrm>
-            <a:off x="7566653" y="3977640"/>
-            <a:ext cx="3742189" cy="457200"/>
+            <a:off x="7717917" y="3977640"/>
+            <a:ext cx="3611118" cy="457200"/>
           </a:xfrm>
           <a:prstGeom prst="rect">
             <a:avLst/>
@@ -4384,8 +4384,8 @@
         </p:nvSpPr>
         <p:spPr>
           <a:xfrm>
-            <a:off x="7566653" y="3977640"/>
-            <a:ext cx="3742189" cy="457200"/>
+            <a:off x="7717917" y="3977640"/>
+            <a:ext cx="3611118" cy="457200"/>
           </a:xfrm>
           <a:prstGeom prst="rect">
             <a:avLst/>
@@ -4409,7 +4409,7 @@
                 <a:ea typeface="Calibri" pitchFamily="34" charset="-122"/>
                 <a:cs typeface="Calibri" pitchFamily="34" charset="-120"/>
               </a:rPr>
-              <a:t>11.619 s</a:t>
+              <a:t>9.478 s</a:t>
             </a:r>
             <a:endParaRPr lang="en-US" sz="1200" dirty="0"/>
           </a:p>
@@ -4423,8 +4423,8 @@
         </p:nvSpPr>
         <p:spPr>
           <a:xfrm>
-            <a:off x="11308841" y="3977640"/>
-            <a:ext cx="304039" cy="457200"/>
+            <a:off x="11329035" y="3977640"/>
+            <a:ext cx="283845" cy="457200"/>
           </a:xfrm>
           <a:prstGeom prst="rect">
             <a:avLst/>
@@ -4498,7 +4498,7 @@
                 <a:ea typeface="Calibri" pitchFamily="34" charset="-122"/>
                 <a:cs typeface="Calibri" pitchFamily="34" charset="-120"/>
               </a:rPr>
-              <a:t>Outage injected  0.519 s</a:t>
+              <a:t>Outage injected  0.714 s</a:t>
             </a:r>
             <a:endParaRPr lang="en-US" sz="1050" dirty="0"/>
           </a:p>
@@ -4562,7 +4562,7 @@
                 <a:ea typeface="Calibri" pitchFamily="34" charset="-122"/>
                 <a:cs typeface="Calibri" pitchFamily="34" charset="-120"/>
               </a:rPr>
-              <a:t>SQL forced failover  15.355 s</a:t>
+              <a:t>SQL forced failover  14.321 s</a:t>
             </a:r>
             <a:endParaRPr lang="en-US" sz="1050" dirty="0"/>
           </a:p>
@@ -4626,7 +4626,7 @@
                 <a:ea typeface="Calibri" pitchFamily="34" charset="-122"/>
                 <a:cs typeface="Calibri" pitchFamily="34" charset="-120"/>
               </a:rPr>
-              <a:t>Traffic Manager reroute  5.916 s</a:t>
+              <a:t>Traffic Manager reroute  3.782 s</a:t>
             </a:r>
             <a:endParaRPr lang="en-US" sz="1050" dirty="0"/>
           </a:p>
@@ -4690,7 +4690,7 @@
                 <a:ea typeface="Calibri" pitchFamily="34" charset="-122"/>
                 <a:cs typeface="Calibri" pitchFamily="34" charset="-120"/>
               </a:rPr>
-              <a:t>DNS + health checks reach DR  11.619 s</a:t>
+              <a:t>DNS + health checks reach DR  9.478 s</a:t>
             </a:r>
             <a:endParaRPr lang="en-US" sz="1050" dirty="0"/>
           </a:p>
@@ -4754,7 +4754,7 @@
                 <a:ea typeface="Calibri" pitchFamily="34" charset="-122"/>
                 <a:cs typeface="Calibri" pitchFamily="34" charset="-120"/>
               </a:rPr>
-              <a:t>Engine bookkeeping  0.944 s</a:t>
+              <a:t>Engine bookkeeping  0.745 s</a:t>
             </a:r>
             <a:endParaRPr lang="en-US" sz="1050" dirty="0"/>
           </a:p>
@@ -4834,7 +4834,7 @@
                 <a:ea typeface="Calibri" pitchFamily="34" charset="-122"/>
                 <a:cs typeface="Calibri" pitchFamily="34" charset="-120"/>
               </a:rPr>
-              <a:t>RTO runs from the injected outage to the first healthy check through Traffic Manager (1 s probes; the previous failed check is shown as the precision window). RPO compares every confirmed heartbeat write with the rows that survived in the new primary. Chaos drill with a surprise fault: 57.4 s.</a:t>
+              <a:t>RTO runs from the injected outage to the first healthy check through Traffic Manager from Southeast Asia (the engine checks every second; the previous failed check is shown as the precision window). RPO: one confirmed write per second, and every write the database acknowledged until the failover completed must exist in the new primary. Chaos drill with a surprise fault: 57.4 s.</a:t>
             </a:r>
             <a:endParaRPr lang="en-US" sz="1250" dirty="0"/>
           </a:p>
@@ -5397,7 +5397,7 @@
                 <a:ea typeface="Calibri" pitchFamily="34" charset="-122"/>
                 <a:cs typeface="Calibri" pitchFamily="34" charset="-120"/>
               </a:rPr>
-              <a:t>per month for the DR set-up</a:t>
+              <a:t>per month for the PaaS DR pair</a:t>
             </a:r>
             <a:endParaRPr lang="en-US" sz="1500" dirty="0"/>
           </a:p>
@@ -5436,7 +5436,7 @@
                 <a:ea typeface="Calibri" pitchFamily="34" charset="-122"/>
                 <a:cs typeface="Calibri" pitchFamily="34" charset="-120"/>
               </a:rPr>
-              <a:t>both regions + Traffic Manager at Azure list prices (Retail Prices API) [13]</a:t>
+              <a:t>2× App Service B1, 2× SQL Basic, Traffic Manager at Azure list prices (Retail Prices API) [13]</a:t>
             </a:r>
             <a:endParaRPr lang="en-US" sz="1150" dirty="0"/>
           </a:p>
@@ -6169,7 +6169,7 @@
                 <a:ea typeface="Calibri" pitchFamily="34" charset="-122"/>
                 <a:cs typeface="Calibri" pitchFamily="34" charset="-120"/>
               </a:rPr>
-              <a:t>Your phone goes red, then reconnects to Southeast Asia in ~30 s with the same balance</a:t>
+              <a:t>Your phone goes red, then reconnects to Southeast Asia in about 35 s with the same balance</a:t>
             </a:r>
             <a:endParaRPr lang="en-US" sz="1350" dirty="0"/>
           </a:p>
@@ -6416,7 +6416,7 @@
                 <a:ea typeface="Calibri" pitchFamily="34" charset="-122"/>
                 <a:cs typeface="Calibri" pitchFamily="34" charset="-120"/>
               </a:rPr>
-              <a:t>weekly, and after every infrastructure change</a:t>
+              <a:t>on a set cadence (e.g. quarterly, as SEBI asks) and after every infrastructure change</a:t>
             </a:r>
             <a:endParaRPr lang="en-US" sz="1200" dirty="0"/>
           </a:p>
@@ -7433,7 +7433,7 @@
                 <a:ea typeface="Calibri" pitchFamily="34" charset="-122"/>
                 <a:cs typeface="Calibri" pitchFamily="34" charset="-120"/>
               </a:rPr>
-              <a:t>Fail over, measure, fail back: 9 live drills, RTO ~34 s, RPO 0</a:t>
+              <a:t>Fail over, measure, fail back: 10 live drills, RTO about 30 s, data loss proven write by write</a:t>
             </a:r>
             <a:endParaRPr lang="en-US" sz="1700" dirty="0"/>
           </a:p>
@@ -10825,7 +10825,7 @@
                 <a:ea typeface="Calibri" pitchFamily="34" charset="-122"/>
                 <a:cs typeface="Calibri" pitchFamily="34" charset="-120"/>
               </a:rPr>
-              <a:t>Cockroach Labs, State of Resilience 2025 (1,000 executives) [11]</a:t>
+              <a:t>Cockroach Labs, State of Resilience 2025 (1,000 executives, 2024 survey) [11]</a:t>
             </a:r>
             <a:endParaRPr lang="en-US" sz="950" dirty="0"/>
           </a:p>
@@ -12609,7 +12609,7 @@
                 <a:ea typeface="Calibri" pitchFamily="34" charset="-122"/>
                 <a:cs typeface="Calibri" pitchFamily="34" charset="-120"/>
               </a:rPr>
-              <a:t>The DR Agent measured 34.35 s</a:t>
+              <a:t>The DR Agent measured 29.04 s</a:t>
             </a:r>
             <a:pPr indent="0" marL="0">
               <a:buNone/>
@@ -12623,7 +12623,7 @@
                 <a:ea typeface="Calibri" pitchFamily="34" charset="-122"/>
                 <a:cs typeface="Calibri" pitchFamily="34" charset="-120"/>
               </a:rPr>
-              <a:t> to recover the same kind of service in our live Azure drill (18 Oct 2026), with zero payments lost, and proves it again on every run.</a:t>
+              <a:t> to recover the same kind of service in a live Azure drill (19 Oct 2026), and proved the data loss write by write: 2.8 s of writes, against a 15-minute target.</a:t>
             </a:r>
             <a:endParaRPr lang="en-US" sz="1450" dirty="0"/>
           </a:p>
@@ -13308,7 +13308,7 @@
                 <a:ea typeface="Calibri" pitchFamily="34" charset="-122"/>
                 <a:cs typeface="Calibri" pitchFamily="34" charset="-120"/>
               </a:rPr>
-              <a:t>builds a 21-step drill from an allowlist of safe actions</a:t>
+              <a:t>builds the drill from an allowlist of safe actions; the engine rejects any unsafe plan</a:t>
             </a:r>
             <a:endParaRPr lang="en-US" sz="1250" dirty="0"/>
           </a:p>
@@ -14621,7 +14621,7 @@
                 <a:ea typeface="Calibri" pitchFamily="34" charset="-122"/>
                 <a:cs typeface="Calibri" pitchFamily="34" charset="-120"/>
               </a:rPr>
-              <a:t>Versioned prompt agents in Azure AI Foundry Agent Service. Every answer must match a strict JSON schema and pass code checks.</a:t>
+              <a:t>Versioned prompt agents in Azure AI Foundry Agent Service. Every answer must match a strict JSON schema; every decision that drives an action is checked by code.</a:t>
             </a:r>
             <a:endParaRPr lang="en-US" sz="1500" dirty="0"/>
           </a:p>
@@ -17348,7 +17348,7 @@
                 <a:ea typeface="Calibri" pitchFamily="34" charset="-122"/>
                 <a:cs typeface="Calibri" pitchFamily="34" charset="-120"/>
               </a:rPr>
-              <a:t>The engine runs only 15 known actions (stop/start app, SQL failover, endpoint on/off, ASR test). Anything else is rejected.</a:t>
+              <a:t>15 known actions only (outage injection, start app, SQL failover, endpoint on/off, health waits, ASR test). Region-changing actions only where the safe sequence puts them.</a:t>
             </a:r>
             <a:endParaRPr lang="en-US" sz="1200" dirty="0"/>
           </a:p>
@@ -17670,7 +17670,7 @@
                 <a:ea typeface="Calibri" pitchFamily="34" charset="-122"/>
                 <a:cs typeface="Calibri" pitchFamily="34" charset="-120"/>
               </a:rPr>
-              <a:t>The plan, the forced database failover, the failback and any Validator fix wait for a named approver.</a:t>
+              <a:t>A named approver signs off the plan; the DB team gives the go for the forced failover; the app team approves failback; a human approves any fix. Plans without these gates are rejected.</a:t>
             </a:r>
             <a:endParaRPr lang="en-US" sz="1200" dirty="0"/>
           </a:p>

</xml_diff>